<commit_message>
Enhance report and PPT with embedded charts, architecture diagram, and styled formatting
- Generated professional system architecture diagram (matplotlib)
- Report now embeds 8 images: architecture, heatmap, scatter, trend, bar, pie, violin, boxplot
- Report sections have bold sub-headings, colored labels, styled code snippets
- PPT slides embed images: architecture (slide 2), heatmap (slide 3), charts (slides 4-5)
- PPT uses color-coded section labels and professional layout

Made-with: Cursor
</commit_message>
<xml_diff>
--- a/BDCCT_PPT.pptx
+++ b/BDCCT_PPT.pptx
@@ -3109,7 +3109,6 @@
           <a:lstStyle/>
           <a:p>
             <a:r>
-              <a:rPr sz="2800"/>
               <a:t>Project Title &amp; Problem Context</a:t>
             </a:r>
           </a:p>
@@ -3132,32 +3131,135 @@
           <a:p>
             <a:pPr/>
             <a:r>
-              <a:rPr sz="1400" b="1"/>
-              <a:t>Project Title: Data-Driven Decision Making in an Organization Using Big Data Technologies</a:t>
-            </a:r>
-          </a:p>
-          <a:p>
-            <a:r>
-              <a:rPr sz="1400"/>
+              <a:rPr sz="1600" b="1">
+                <a:solidFill>
+                  <a:srgbClr val="2C3E50"/>
+                </a:solidFill>
+                <a:latin typeface="Calibri"/>
+              </a:rPr>
+              <a:t>Project Title:</a:t>
+            </a:r>
+          </a:p>
+          <a:p>
+            <a:r>
+              <a:rPr sz="1400" b="0">
+                <a:solidFill>
+                  <a:srgbClr val="2980B9"/>
+                </a:solidFill>
+                <a:latin typeface="Calibri"/>
+              </a:rPr>
+              <a:t>Data-Driven Decision Making in an Organization</a:t>
+            </a:r>
+          </a:p>
+          <a:p>
+            <a:r>
+              <a:rPr sz="1400" b="0">
+                <a:solidFill>
+                  <a:srgbClr val="2980B9"/>
+                </a:solidFill>
+                <a:latin typeface="Calibri"/>
+              </a:rPr>
+              <a:t>Using Big Data Technologies</a:t>
+            </a:r>
+          </a:p>
+          <a:p>
+            <a:r>
+              <a:rPr sz="1000" b="0">
+                <a:latin typeface="Calibri"/>
+              </a:rPr>
+              <a:t/>
+            </a:r>
+          </a:p>
+          <a:p>
+            <a:r>
+              <a:rPr sz="1200" b="0">
+                <a:solidFill>
+                  <a:srgbClr val="505050"/>
+                </a:solidFill>
+                <a:latin typeface="Calibri"/>
+              </a:rPr>
               <a:t>Name &amp; USN: ____________________ | ____________________</a:t>
             </a:r>
           </a:p>
           <a:p>
             <a:r>
-              <a:rPr sz="1400"/>
+              <a:rPr sz="1200" b="0">
+                <a:solidFill>
+                  <a:srgbClr val="505050"/>
+                </a:solidFill>
+                <a:latin typeface="Calibri"/>
+              </a:rPr>
               <a:t>Domain: Big Data Analytics &amp; Organizational Decision Intelligence</a:t>
             </a:r>
           </a:p>
           <a:p>
             <a:r>
-              <a:rPr sz="1400"/>
-              <a:t>Problem Statement: Organizations generate vast operational data but lack integrated pipelines to convert it into high-quality decisions. Poor data quality, high error rates, and fragmented analytics reduce decision effectiveness by up to 40%.</a:t>
-            </a:r>
-          </a:p>
-          <a:p>
-            <a:r>
-              <a:rPr sz="1400"/>
-              <a:t>Target Users: C-suite executives, Department heads, Data analysts, HR managers</a:t>
+              <a:rPr sz="800" b="0">
+                <a:latin typeface="Calibri"/>
+              </a:rPr>
+              <a:t/>
+            </a:r>
+          </a:p>
+          <a:p>
+            <a:r>
+              <a:rPr sz="1300" b="1">
+                <a:solidFill>
+                  <a:srgbClr val="C0392B"/>
+                </a:solidFill>
+                <a:latin typeface="Calibri"/>
+              </a:rPr>
+              <a:t>Problem Statement:</a:t>
+            </a:r>
+          </a:p>
+          <a:p>
+            <a:r>
+              <a:rPr sz="1200" b="0">
+                <a:latin typeface="Calibri"/>
+              </a:rPr>
+              <a:t>Organizations generate vast operational data but lack integrated</a:t>
+            </a:r>
+          </a:p>
+          <a:p>
+            <a:r>
+              <a:rPr sz="1200" b="0">
+                <a:latin typeface="Calibri"/>
+              </a:rPr>
+              <a:t>pipelines to convert it into high-quality decisions. Poor data quality,</a:t>
+            </a:r>
+          </a:p>
+          <a:p>
+            <a:r>
+              <a:rPr sz="1200" b="0">
+                <a:latin typeface="Calibri"/>
+              </a:rPr>
+              <a:t>high error rates, and fragmented analytics reduce decision</a:t>
+            </a:r>
+          </a:p>
+          <a:p>
+            <a:r>
+              <a:rPr sz="1200" b="0">
+                <a:latin typeface="Calibri"/>
+              </a:rPr>
+              <a:t>effectiveness by up to 40%.</a:t>
+            </a:r>
+          </a:p>
+          <a:p>
+            <a:r>
+              <a:rPr sz="800" b="0">
+                <a:latin typeface="Calibri"/>
+              </a:rPr>
+              <a:t/>
+            </a:r>
+          </a:p>
+          <a:p>
+            <a:r>
+              <a:rPr sz="1100" b="1">
+                <a:solidFill>
+                  <a:srgbClr val="27AE60"/>
+                </a:solidFill>
+                <a:latin typeface="Calibri"/>
+              </a:rPr>
+              <a:t>Target Users: C-suite executives | Department heads | Data analysts | HR managers</a:t>
             </a:r>
           </a:p>
         </p:txBody>
@@ -3201,91 +3303,61 @@
           </a:p>
         </p:txBody>
       </p:sp>
-      <p:sp>
-        <p:nvSpPr>
-          <p:cNvPr id="3" name="Content Placeholder 2"/>
-          <p:cNvSpPr>
-            <a:spLocks noGrp="1"/>
-          </p:cNvSpPr>
-          <p:nvPr>
-            <p:ph idx="1"/>
-          </p:nvPr>
-        </p:nvSpPr>
-        <p:spPr/>
-        <p:txBody>
-          <a:bodyPr/>
-          <a:lstStyle/>
-          <a:p>
-            <a:pPr/>
-            <a:r>
-              <a:rPr sz="1300"/>
-              <a:t>Data Source (CSV/ERP)  →  Ingestion (GCP Cloud Storage)  →  Processing (PySpark on GCP Dataproc)  →  Storage (Parquet)  →  Dashboard (Streamlit)</a:t>
-            </a:r>
-          </a:p>
-          <a:p>
-            <a:r>
-              <a:rPr sz="1300"/>
-              <a:t/>
-            </a:r>
-          </a:p>
-          <a:p>
-            <a:r>
-              <a:rPr sz="1300"/>
-              <a:t>Tools &amp; Technologies:</a:t>
-            </a:r>
-          </a:p>
-          <a:p>
-            <a:pPr lvl="1"/>
-            <a:r>
-              <a:rPr sz="1300"/>
-              <a:t>• Apache Spark (PySpark) — Distributed data processing engine</a:t>
-            </a:r>
-          </a:p>
-          <a:p>
-            <a:pPr lvl="1"/>
-            <a:r>
-              <a:rPr sz="1300"/>
-              <a:t>• GCP Dataproc — Managed Spark cluster with auto-scaling</a:t>
-            </a:r>
-          </a:p>
-          <a:p>
-            <a:pPr lvl="1"/>
-            <a:r>
-              <a:rPr sz="1300"/>
-              <a:t>• GCP Cloud Storage — Durable raw &amp; processed data lake</a:t>
-            </a:r>
-          </a:p>
-          <a:p>
-            <a:pPr lvl="1"/>
-            <a:r>
-              <a:rPr sz="1300"/>
-              <a:t>• Apache Parquet — Columnar storage with Snappy compression</a:t>
-            </a:r>
-          </a:p>
-          <a:p>
-            <a:pPr lvl="1"/>
-            <a:r>
-              <a:rPr sz="1300"/>
-              <a:t>• Streamlit — Interactive Python dashboard framework</a:t>
-            </a:r>
-          </a:p>
-          <a:p>
-            <a:pPr lvl="1"/>
-            <a:r>
-              <a:rPr sz="1300"/>
-              <a:t>• Plotly / Matplotlib / Seaborn — Visualization libraries</a:t>
-            </a:r>
-          </a:p>
-          <a:p>
-            <a:r>
-              <a:rPr sz="1300"/>
-              <a:t/>
-            </a:r>
-          </a:p>
-          <a:p>
-            <a:r>
-              <a:rPr sz="1300"/>
-              <a:t>Workflow: Raw CSV → Schema Validation → Cleaning (Nulls, Duplicates, Outliers) → Feature Engineering (9 derived features) → Aggregations → Parquet Storage → Interactive Dashboard → Business Insights</a:t>
+      <p:pic>
+        <p:nvPicPr>
+          <p:cNvPr id="3" name="Picture 2" descr="00_system_architecture.png"/>
+          <p:cNvPicPr>
+            <a:picLocks noChangeAspect="1"/>
+          </p:cNvPicPr>
+          <p:nvPr/>
+        </p:nvPicPr>
+        <p:blipFill>
+          <a:blip r:embed="rId2"/>
+          <a:stretch>
+            <a:fillRect/>
+          </a:stretch>
+        </p:blipFill>
+        <p:spPr>
+          <a:xfrm>
+            <a:off x="365760" y="1371600"/>
+            <a:ext cx="8412480" cy="5990751"/>
+          </a:xfrm>
+          <a:prstGeom prst="rect">
+            <a:avLst/>
+          </a:prstGeom>
+        </p:spPr>
+      </p:pic>
+      <p:sp>
+        <p:nvSpPr>
+          <p:cNvPr id="4" name="TextBox 3"/>
+          <p:cNvSpPr txBox="1"/>
+          <p:nvPr/>
+        </p:nvSpPr>
+        <p:spPr>
+          <a:xfrm>
+            <a:off x="457200" y="5943600"/>
+            <a:ext cx="8229600" cy="731520"/>
+          </a:xfrm>
+          <a:prstGeom prst="rect">
+            <a:avLst/>
+          </a:prstGeom>
+          <a:noFill/>
+        </p:spPr>
+        <p:txBody>
+          <a:bodyPr wrap="square">
+            <a:spAutoFit/>
+          </a:bodyPr>
+          <a:lstStyle/>
+          <a:p>
+            <a:pPr algn="l"/>
+            <a:r>
+              <a:rPr sz="1000" b="1">
+                <a:solidFill>
+                  <a:srgbClr val="646464"/>
+                </a:solidFill>
+                <a:latin typeface="Calibri"/>
+              </a:rPr>
+              <a:t>Tools: PySpark | GCP Dataproc | Cloud Storage | Parquet | Streamlit | Plotly | Python</a:t>
             </a:r>
           </a:p>
         </p:txBody>
@@ -3331,111 +3403,274 @@
       </p:sp>
       <p:sp>
         <p:nvSpPr>
-          <p:cNvPr id="3" name="Content Placeholder 2"/>
-          <p:cNvSpPr>
-            <a:spLocks noGrp="1"/>
-          </p:cNvSpPr>
-          <p:nvPr>
-            <p:ph idx="1"/>
-          </p:nvPr>
-        </p:nvSpPr>
-        <p:spPr/>
-        <p:txBody>
-          <a:bodyPr/>
-          <a:lstStyle/>
-          <a:p>
-            <a:pPr/>
-            <a:r>
-              <a:rPr sz="1200"/>
-              <a:t>Dataset: data_driven_decision_realistic.csv — 123,847 rows × 15 columns (2024–2025)</a:t>
-            </a:r>
-          </a:p>
-          <a:p>
-            <a:r>
-              <a:rPr sz="1200"/>
+          <p:cNvPr id="3" name="TextBox 2"/>
+          <p:cNvSpPr txBox="1"/>
+          <p:nvPr/>
+        </p:nvSpPr>
+        <p:spPr>
+          <a:xfrm>
+            <a:off x="274320" y="1371600"/>
+            <a:ext cx="4389120" cy="5029200"/>
+          </a:xfrm>
+          <a:prstGeom prst="rect">
+            <a:avLst/>
+          </a:prstGeom>
+          <a:noFill/>
+        </p:spPr>
+        <p:txBody>
+          <a:bodyPr wrap="square">
+            <a:spAutoFit/>
+          </a:bodyPr>
+          <a:lstStyle/>
+          <a:p>
+            <a:pPr algn="l"/>
+            <a:r>
+              <a:rPr sz="1000" b="1">
+                <a:latin typeface="Calibri"/>
+              </a:rPr>
+              <a:t>Dataset: 123,847 rows × 15 columns</a:t>
+            </a:r>
+          </a:p>
+          <a:p>
+            <a:pPr algn="l"/>
+            <a:r>
+              <a:rPr sz="1000" b="1">
+                <a:latin typeface="Calibri"/>
+              </a:rPr>
+              <a:t>Period: Jan 2024 – Dec 2025</a:t>
+            </a:r>
+          </a:p>
+          <a:p>
+            <a:pPr algn="l"/>
+            <a:r>
+              <a:rPr sz="1000">
+                <a:latin typeface="Calibri"/>
+              </a:rPr>
               <a:t/>
             </a:r>
           </a:p>
           <a:p>
-            <a:r>
-              <a:rPr sz="1200"/>
+            <a:pPr algn="l"/>
+            <a:r>
+              <a:rPr sz="1000" b="1">
+                <a:latin typeface="Calibri"/>
+              </a:rPr>
               <a:t>Key Operations:</a:t>
             </a:r>
           </a:p>
           <a:p>
-            <a:pPr lvl="1"/>
-            <a:r>
-              <a:rPr sz="1200"/>
-              <a:t>• Data Cleaning: Null imputation (median), duplicate removal, outlier capping (IQR method), negative value correction</a:t>
-            </a:r>
-          </a:p>
-          <a:p>
-            <a:pPr lvl="1"/>
-            <a:r>
-              <a:rPr sz="1200"/>
-              <a:t>• Feature Engineering: experience_training_ratio, efficiency_score, quality_error_interaction, temporal features (month, quarter, day_of_week)</a:t>
-            </a:r>
-          </a:p>
-          <a:p>
-            <a:pPr lvl="1"/>
-            <a:r>
-              <a:rPr sz="1200"/>
-              <a:t>• Aggregations: Department-wise (avg impact, performance, sales), Region-wise (satisfaction, attrition), Quarterly trends</a:t>
-            </a:r>
-          </a:p>
-          <a:p>
-            <a:pPr lvl="1"/>
-            <a:r>
-              <a:rPr sz="1200"/>
-              <a:t>• Filtering: High error rate cases (&gt;0.3), High attrition risk employees (≥0.7)</a:t>
-            </a:r>
-          </a:p>
-          <a:p>
-            <a:r>
-              <a:rPr sz="1200"/>
+            <a:pPr algn="l" lvl="1"/>
+            <a:r>
+              <a:rPr sz="1000">
+                <a:latin typeface="Calibri"/>
+              </a:rPr>
+              <a:t>• Null Imputation (median)</a:t>
+            </a:r>
+          </a:p>
+          <a:p>
+            <a:pPr algn="l" lvl="1"/>
+            <a:r>
+              <a:rPr sz="1000">
+                <a:latin typeface="Calibri"/>
+              </a:rPr>
+              <a:t>• Duplicate Removal</a:t>
+            </a:r>
+          </a:p>
+          <a:p>
+            <a:pPr algn="l" lvl="1"/>
+            <a:r>
+              <a:rPr sz="1000">
+                <a:latin typeface="Calibri"/>
+              </a:rPr>
+              <a:t>• Outlier Capping (IQR method)</a:t>
+            </a:r>
+          </a:p>
+          <a:p>
+            <a:pPr algn="l" lvl="1"/>
+            <a:r>
+              <a:rPr sz="1000">
+                <a:latin typeface="Calibri"/>
+              </a:rPr>
+              <a:t>• Feature Engineering (9 new features)</a:t>
+            </a:r>
+          </a:p>
+          <a:p>
+            <a:pPr algn="l" lvl="1"/>
+            <a:r>
+              <a:rPr sz="1000">
+                <a:latin typeface="Calibri"/>
+              </a:rPr>
+              <a:t>• Dept/Region Aggregations</a:t>
+            </a:r>
+          </a:p>
+          <a:p>
+            <a:pPr algn="l"/>
+            <a:r>
+              <a:rPr sz="1000">
+                <a:latin typeface="Calibri"/>
+              </a:rPr>
               <a:t/>
             </a:r>
           </a:p>
           <a:p>
-            <a:r>
-              <a:rPr sz="1200"/>
+            <a:pPr algn="l"/>
+            <a:r>
+              <a:rPr sz="1000" b="1">
+                <a:solidFill>
+                  <a:srgbClr val="2980B9"/>
+                </a:solidFill>
+                <a:latin typeface="Calibri"/>
+              </a:rPr>
               <a:t>Code Snippet:</a:t>
             </a:r>
           </a:p>
           <a:p>
-            <a:r>
-              <a:rPr sz="1200"/>
-              <a:t>  df = spark.read.csv(path, header=True, schema=schema)</a:t>
-            </a:r>
-          </a:p>
-          <a:p>
-            <a:r>
-              <a:rPr sz="1200"/>
-              <a:t>  df = df.dropDuplicates()</a:t>
-            </a:r>
-          </a:p>
-          <a:p>
-            <a:r>
-              <a:rPr sz="1200"/>
-              <a:t>  df = df.withColumn('Efficiency_Score', col('Performance_Score')/(col('Processing_Time_sec')+1))</a:t>
-            </a:r>
-          </a:p>
-          <a:p>
-            <a:r>
-              <a:rPr sz="1200"/>
-              <a:t>  df.write.partitionBy('Department').parquet('processed_data/')</a:t>
-            </a:r>
-          </a:p>
-          <a:p>
-            <a:r>
-              <a:rPr sz="1200"/>
+            <a:pPr algn="l"/>
+            <a:r>
+              <a:rPr sz="1000">
+                <a:solidFill>
+                  <a:srgbClr val="2980B9"/>
+                </a:solidFill>
+                <a:latin typeface="Calibri"/>
+              </a:rPr>
+              <a:t>df = spark.read.csv(path, schema=schema)</a:t>
+            </a:r>
+          </a:p>
+          <a:p>
+            <a:pPr algn="l"/>
+            <a:r>
+              <a:rPr sz="1000">
+                <a:solidFill>
+                  <a:srgbClr val="2980B9"/>
+                </a:solidFill>
+                <a:latin typeface="Calibri"/>
+              </a:rPr>
+              <a:t>df = df.dropDuplicates()</a:t>
+            </a:r>
+          </a:p>
+          <a:p>
+            <a:pPr algn="l"/>
+            <a:r>
+              <a:rPr sz="1000">
+                <a:solidFill>
+                  <a:srgbClr val="2980B9"/>
+                </a:solidFill>
+                <a:latin typeface="Calibri"/>
+              </a:rPr>
+              <a:t>df = df.withColumn('Efficiency_Score',</a:t>
+            </a:r>
+          </a:p>
+          <a:p>
+            <a:pPr algn="l"/>
+            <a:r>
+              <a:rPr sz="1000">
+                <a:solidFill>
+                  <a:srgbClr val="2980B9"/>
+                </a:solidFill>
+                <a:latin typeface="Calibri"/>
+              </a:rPr>
+              <a:t>    col('Perf')/(col('Time')+1))</a:t>
+            </a:r>
+          </a:p>
+          <a:p>
+            <a:pPr algn="l"/>
+            <a:r>
+              <a:rPr sz="1000">
+                <a:solidFill>
+                  <a:srgbClr val="2980B9"/>
+                </a:solidFill>
+                <a:latin typeface="Calibri"/>
+              </a:rPr>
+              <a:t>df.write.partitionBy('Department')</a:t>
+            </a:r>
+          </a:p>
+          <a:p>
+            <a:pPr algn="l"/>
+            <a:r>
+              <a:rPr sz="1000">
+                <a:solidFill>
+                  <a:srgbClr val="2980B9"/>
+                </a:solidFill>
+                <a:latin typeface="Calibri"/>
+              </a:rPr>
+              <a:t>    .parquet('processed_data/')</a:t>
+            </a:r>
+          </a:p>
+          <a:p>
+            <a:pPr algn="l"/>
+            <a:r>
+              <a:rPr sz="1000" b="1">
+                <a:latin typeface="Calibri"/>
+              </a:rPr>
               <a:t/>
             </a:r>
           </a:p>
           <a:p>
-            <a:r>
-              <a:rPr sz="1200"/>
-              <a:t>Output: 24 columns (9 engineered), Parquet format, partitioned by Department</a:t>
+            <a:pPr algn="l"/>
+            <a:r>
+              <a:rPr sz="1000">
+                <a:latin typeface="Calibri"/>
+              </a:rPr>
+              <a:t>Output: 24 cols, Parquet, partitioned</a:t>
+            </a:r>
+          </a:p>
+        </p:txBody>
+      </p:sp>
+      <p:pic>
+        <p:nvPicPr>
+          <p:cNvPr id="4" name="Picture 3" descr="01_correlation_heatmap.png"/>
+          <p:cNvPicPr>
+            <a:picLocks noChangeAspect="1"/>
+          </p:cNvPicPr>
+          <p:nvPr/>
+        </p:nvPicPr>
+        <p:blipFill>
+          <a:blip r:embed="rId2"/>
+          <a:stretch>
+            <a:fillRect/>
+          </a:stretch>
+        </p:blipFill>
+        <p:spPr>
+          <a:xfrm>
+            <a:off x="4846320" y="1371600"/>
+            <a:ext cx="4023360" cy="3597271"/>
+          </a:xfrm>
+          <a:prstGeom prst="rect">
+            <a:avLst/>
+          </a:prstGeom>
+        </p:spPr>
+      </p:pic>
+      <p:sp>
+        <p:nvSpPr>
+          <p:cNvPr id="5" name="TextBox 4"/>
+          <p:cNvSpPr txBox="1"/>
+          <p:nvPr/>
+        </p:nvSpPr>
+        <p:spPr>
+          <a:xfrm>
+            <a:off x="5029200" y="5669280"/>
+            <a:ext cx="3657600" cy="365760"/>
+          </a:xfrm>
+          <a:prstGeom prst="rect">
+            <a:avLst/>
+          </a:prstGeom>
+          <a:noFill/>
+        </p:spPr>
+        <p:txBody>
+          <a:bodyPr wrap="square">
+            <a:spAutoFit/>
+          </a:bodyPr>
+          <a:lstStyle/>
+          <a:p>
+            <a:pPr algn="ctr"/>
+            <a:r>
+              <a:rPr sz="800">
+                <a:solidFill>
+                  <a:srgbClr val="787878"/>
+                </a:solidFill>
+                <a:latin typeface="Calibri"/>
+              </a:rPr>
+              <a:t>Correlation Matrix of Key Variables</a:t>
             </a:r>
           </a:p>
         </p:txBody>
@@ -3479,73 +3714,139 @@
           </a:p>
         </p:txBody>
       </p:sp>
-      <p:sp>
-        <p:nvSpPr>
-          <p:cNvPr id="3" name="Content Placeholder 2"/>
-          <p:cNvSpPr>
-            <a:spLocks noGrp="1"/>
-          </p:cNvSpPr>
-          <p:nvPr>
-            <p:ph idx="1"/>
-          </p:nvPr>
-        </p:nvSpPr>
-        <p:spPr/>
-        <p:txBody>
-          <a:bodyPr/>
-          <a:lstStyle/>
-          <a:p>
-            <a:pPr/>
-            <a:r>
-              <a:rPr sz="1300"/>
-              <a:t>Dashboard: Streamlit interactive dashboard with KPI cards, 6 chart types, sidebar filters</a:t>
-            </a:r>
-          </a:p>
-          <a:p>
-            <a:r>
-              <a:rPr sz="1300"/>
+      <p:pic>
+        <p:nvPicPr>
+          <p:cNvPr id="3" name="Picture 2" descr="02_dept_decision_impact.png"/>
+          <p:cNvPicPr>
+            <a:picLocks noChangeAspect="1"/>
+          </p:cNvPicPr>
+          <p:nvPr/>
+        </p:nvPicPr>
+        <p:blipFill>
+          <a:blip r:embed="rId2"/>
+          <a:stretch>
+            <a:fillRect/>
+          </a:stretch>
+        </p:blipFill>
+        <p:spPr>
+          <a:xfrm>
+            <a:off x="274320" y="1280160"/>
+            <a:ext cx="4114800" cy="2605748"/>
+          </a:xfrm>
+          <a:prstGeom prst="rect">
+            <a:avLst/>
+          </a:prstGeom>
+        </p:spPr>
+      </p:pic>
+      <p:pic>
+        <p:nvPicPr>
+          <p:cNvPr id="4" name="Picture 3" descr="04_monthly_trend.png"/>
+          <p:cNvPicPr>
+            <a:picLocks noChangeAspect="1"/>
+          </p:cNvPicPr>
+          <p:nvPr/>
+        </p:nvPicPr>
+        <p:blipFill>
+          <a:blip r:embed="rId3"/>
+          <a:stretch>
+            <a:fillRect/>
+          </a:stretch>
+        </p:blipFill>
+        <p:spPr>
+          <a:xfrm>
+            <a:off x="4572000" y="1280160"/>
+            <a:ext cx="4297680" cy="1918326"/>
+          </a:xfrm>
+          <a:prstGeom prst="rect">
+            <a:avLst/>
+          </a:prstGeom>
+        </p:spPr>
+      </p:pic>
+      <p:sp>
+        <p:nvSpPr>
+          <p:cNvPr id="5" name="TextBox 4"/>
+          <p:cNvSpPr txBox="1"/>
+          <p:nvPr/>
+        </p:nvSpPr>
+        <p:spPr>
+          <a:xfrm>
+            <a:off x="274320" y="4206240"/>
+            <a:ext cx="8503920" cy="2560320"/>
+          </a:xfrm>
+          <a:prstGeom prst="rect">
+            <a:avLst/>
+          </a:prstGeom>
+          <a:noFill/>
+        </p:spPr>
+        <p:txBody>
+          <a:bodyPr wrap="square">
+            <a:spAutoFit/>
+          </a:bodyPr>
+          <a:lstStyle/>
+          <a:p>
+            <a:pPr algn="l"/>
+            <a:r>
+              <a:rPr sz="1100" b="1">
+                <a:solidFill>
+                  <a:srgbClr val="2C3E50"/>
+                </a:solidFill>
+                <a:latin typeface="Calibri"/>
+              </a:rPr>
+              <a:t>Key Business Insights:</a:t>
+            </a:r>
+          </a:p>
+          <a:p>
+            <a:pPr algn="l"/>
+            <a:r>
+              <a:rPr sz="1100">
+                <a:latin typeface="Calibri"/>
+              </a:rPr>
               <a:t/>
             </a:r>
           </a:p>
           <a:p>
-            <a:r>
-              <a:rPr sz="1300"/>
-              <a:t>Key Insight 1: Data Quality Score is the strongest predictor of Decision Impact (r = 0.736). Organizations should prioritize data quality programs to maximize decision effectiveness.</a:t>
-            </a:r>
-          </a:p>
-          <a:p>
-            <a:r>
-              <a:rPr sz="1300"/>
-              <a:t/>
-            </a:r>
-          </a:p>
-          <a:p>
-            <a:r>
-              <a:rPr sz="1300"/>
-              <a:t>Key Insight 2: Employees with &gt;40 training hours/year achieve 27% higher performance scores (4.76 vs 3.76). Clear ROI on training investment.</a:t>
-            </a:r>
-          </a:p>
-          <a:p>
-            <a:r>
-              <a:rPr sz="1300"/>
-              <a:t/>
-            </a:r>
-          </a:p>
-          <a:p>
-            <a:r>
-              <a:rPr sz="1300"/>
-              <a:t>Key Insight 3: Error rates above 15% cause a 43% drop in Decision Impact Score (77.7 → 44.6). Implement automated quality gates at this threshold.</a:t>
-            </a:r>
-          </a:p>
-          <a:p>
-            <a:r>
-              <a:rPr sz="1300"/>
-              <a:t/>
-            </a:r>
-          </a:p>
-          <a:p>
-            <a:r>
-              <a:rPr sz="1300"/>
-              <a:t>Additional: Engineering department leads in Decision Impact (+40% vs HR) due to superior data quality and training investment. Attrition Risk and Customer Satisfaction show strong inverse correlation (r = -0.875).</a:t>
+            <a:pPr algn="l" lvl="1"/>
+            <a:r>
+              <a:rPr sz="1100">
+                <a:latin typeface="Calibri"/>
+              </a:rPr>
+              <a:t>• Insight 1: Data Quality is the strongest predictor of Decision Impact (r = 0.736)</a:t>
+            </a:r>
+          </a:p>
+          <a:p>
+            <a:pPr algn="l" lvl="1"/>
+            <a:r>
+              <a:rPr sz="1100">
+                <a:latin typeface="Calibri"/>
+              </a:rPr>
+              <a:t>• Insight 2: Training &gt;40 hrs/yr yields 27% higher performance (4.76 vs 3.76)</a:t>
+            </a:r>
+          </a:p>
+          <a:p>
+            <a:pPr algn="l" lvl="1"/>
+            <a:r>
+              <a:rPr sz="1100">
+                <a:latin typeface="Calibri"/>
+              </a:rPr>
+              <a:t>• Insight 3: Error rates &gt;15% cause 43% drop in Decision Impact (77.7 → 44.6)</a:t>
+            </a:r>
+          </a:p>
+          <a:p>
+            <a:pPr algn="l" lvl="1"/>
+            <a:r>
+              <a:rPr sz="1100">
+                <a:latin typeface="Calibri"/>
+              </a:rPr>
+              <a:t>• Insight 4: Engineering leads Impact (+40% vs HR) — best data quality + training</a:t>
+            </a:r>
+          </a:p>
+          <a:p>
+            <a:pPr algn="l" lvl="1"/>
+            <a:r>
+              <a:rPr sz="1100">
+                <a:latin typeface="Calibri"/>
+              </a:rPr>
+              <a:t>• Insight 5: Attrition Risk ↔ Satisfaction feedback loop (r = –0.875)</a:t>
             </a:r>
           </a:p>
         </p:txBody>
@@ -3591,121 +3892,228 @@
       </p:sp>
       <p:sp>
         <p:nvSpPr>
-          <p:cNvPr id="3" name="Content Placeholder 2"/>
-          <p:cNvSpPr>
-            <a:spLocks noGrp="1"/>
-          </p:cNvSpPr>
-          <p:nvPr>
-            <p:ph idx="1"/>
-          </p:nvPr>
-        </p:nvSpPr>
-        <p:spPr/>
-        <p:txBody>
-          <a:bodyPr/>
-          <a:lstStyle/>
-          <a:p>
-            <a:pPr/>
-            <a:r>
-              <a:rPr sz="1200"/>
+          <p:cNvPr id="3" name="TextBox 2"/>
+          <p:cNvSpPr txBox="1"/>
+          <p:nvPr/>
+        </p:nvSpPr>
+        <p:spPr>
+          <a:xfrm>
+            <a:off x="274320" y="1280160"/>
+            <a:ext cx="4206240" cy="2743200"/>
+          </a:xfrm>
+          <a:prstGeom prst="rect">
+            <a:avLst/>
+          </a:prstGeom>
+          <a:noFill/>
+        </p:spPr>
+        <p:txBody>
+          <a:bodyPr wrap="square">
+            <a:spAutoFit/>
+          </a:bodyPr>
+          <a:lstStyle/>
+          <a:p>
+            <a:pPr algn="l"/>
+            <a:r>
+              <a:rPr sz="1000" b="1">
+                <a:solidFill>
+                  <a:srgbClr val="2C3E50"/>
+                </a:solidFill>
+                <a:latin typeface="Calibri"/>
+              </a:rPr>
               <a:t>Real-World Applications:</a:t>
             </a:r>
           </a:p>
           <a:p>
-            <a:pPr lvl="1"/>
-            <a:r>
-              <a:rPr sz="1200"/>
-              <a:t>• Management Consulting — Analyze client decision quality, identify bottlenecks, prescribe interventions</a:t>
-            </a:r>
-          </a:p>
-          <a:p>
-            <a:pPr lvl="1"/>
-            <a:r>
-              <a:rPr sz="1200"/>
-              <a:t>• Healthcare Administration — Monitor clinical decision errors, track staff training compliance, predict attrition</a:t>
-            </a:r>
-          </a:p>
-          <a:p>
-            <a:pPr lvl="1"/>
-            <a:r>
-              <a:rPr sz="1200"/>
-              <a:t>• Retail &amp; E-Commerce — Optimize pricing/marketing decisions across regions and product categories</a:t>
-            </a:r>
-          </a:p>
-          <a:p>
-            <a:pPr lvl="1"/>
-            <a:r>
-              <a:rPr sz="1200"/>
-              <a:t>• Financial Services — Quality-gate credit decisions, flag high-error-rate processing pipelines</a:t>
-            </a:r>
-          </a:p>
-          <a:p>
-            <a:r>
-              <a:rPr sz="1200"/>
+            <a:pPr algn="l"/>
+            <a:r>
+              <a:rPr sz="1000">
+                <a:latin typeface="Calibri"/>
+              </a:rPr>
               <a:t/>
             </a:r>
           </a:p>
           <a:p>
-            <a:r>
-              <a:rPr sz="1200"/>
+            <a:pPr algn="l" lvl="1"/>
+            <a:r>
+              <a:rPr sz="1000">
+                <a:latin typeface="Calibri"/>
+              </a:rPr>
+              <a:t>• Consulting — Client decision quality analysis</a:t>
+            </a:r>
+          </a:p>
+          <a:p>
+            <a:pPr algn="l" lvl="1"/>
+            <a:r>
+              <a:rPr sz="1000">
+                <a:latin typeface="Calibri"/>
+              </a:rPr>
+              <a:t>• Healthcare — Clinical error monitoring</a:t>
+            </a:r>
+          </a:p>
+          <a:p>
+            <a:pPr algn="l" lvl="1"/>
+            <a:r>
+              <a:rPr sz="1000">
+                <a:latin typeface="Calibri"/>
+              </a:rPr>
+              <a:t>• Retail — Regional decision optimization</a:t>
+            </a:r>
+          </a:p>
+          <a:p>
+            <a:pPr algn="l" lvl="1"/>
+            <a:r>
+              <a:rPr sz="1000">
+                <a:latin typeface="Calibri"/>
+              </a:rPr>
+              <a:t>• Finance — Error-rate quality gates</a:t>
+            </a:r>
+          </a:p>
+          <a:p>
+            <a:pPr algn="l"/>
+            <a:r>
+              <a:rPr sz="1000">
+                <a:latin typeface="Calibri"/>
+              </a:rPr>
+              <a:t/>
+            </a:r>
+          </a:p>
+          <a:p>
+            <a:pPr algn="l"/>
+            <a:r>
+              <a:rPr sz="1000" b="1">
+                <a:solidFill>
+                  <a:srgbClr val="2C3E50"/>
+                </a:solidFill>
+                <a:latin typeface="Calibri"/>
+              </a:rPr>
               <a:t>Scalability:</a:t>
             </a:r>
           </a:p>
           <a:p>
-            <a:pPr lvl="1"/>
-            <a:r>
-              <a:rPr sz="1200"/>
-              <a:t>• Horizontal Scaling: GCP Dataproc clusters (10–100 nodes) for petabyte-scale data</a:t>
-            </a:r>
-          </a:p>
-          <a:p>
-            <a:pPr lvl="1"/>
-            <a:r>
-              <a:rPr sz="1200"/>
-              <a:t>• Partition Strategy: Composite partitioning (Department + Region + Year) for efficient queries</a:t>
-            </a:r>
-          </a:p>
-          <a:p>
-            <a:pPr lvl="1"/>
-            <a:r>
-              <a:rPr sz="1200"/>
-              <a:t>• Storage: Parquet + Snappy compression (60–80% reduction), Delta Lake for ACID transactions</a:t>
-            </a:r>
-          </a:p>
-          <a:p>
-            <a:r>
-              <a:rPr sz="1200"/>
+            <a:pPr algn="l" lvl="1"/>
+            <a:r>
+              <a:rPr sz="1000">
+                <a:latin typeface="Calibri"/>
+              </a:rPr>
+              <a:t>• GCP Dataproc: 10–100 node clusters</a:t>
+            </a:r>
+          </a:p>
+          <a:p>
+            <a:pPr algn="l" lvl="1"/>
+            <a:r>
+              <a:rPr sz="1000">
+                <a:latin typeface="Calibri"/>
+              </a:rPr>
+              <a:t>• Parquet + Snappy: 60–80% compression</a:t>
+            </a:r>
+          </a:p>
+          <a:p>
+            <a:pPr algn="l" lvl="1"/>
+            <a:r>
+              <a:rPr sz="1000">
+                <a:latin typeface="Calibri"/>
+              </a:rPr>
+              <a:t>• Delta Lake for ACID transactions</a:t>
+            </a:r>
+          </a:p>
+          <a:p>
+            <a:pPr algn="l"/>
+            <a:r>
+              <a:rPr sz="1000">
+                <a:latin typeface="Calibri"/>
+              </a:rPr>
               <a:t/>
             </a:r>
           </a:p>
           <a:p>
-            <a:r>
-              <a:rPr sz="1200"/>
-              <a:t>Future Improvements:</a:t>
-            </a:r>
-          </a:p>
-          <a:p>
-            <a:pPr lvl="1"/>
-            <a:r>
-              <a:rPr sz="1200"/>
-              <a:t>• Real-time processing via Spark Structured Streaming</a:t>
-            </a:r>
-          </a:p>
-          <a:p>
-            <a:pPr lvl="1"/>
-            <a:r>
-              <a:rPr sz="1200"/>
-              <a:t>• ML models (Random Forest, XGBoost) to predict Decision Impact proactively</a:t>
-            </a:r>
-          </a:p>
-          <a:p>
-            <a:pPr lvl="1"/>
-            <a:r>
-              <a:rPr sz="1200"/>
-              <a:t>• Automated alerts when error rates exceed thresholds</a:t>
-            </a:r>
-          </a:p>
-        </p:txBody>
-      </p:sp>
+            <a:pPr algn="l"/>
+            <a:r>
+              <a:rPr sz="1000" b="1">
+                <a:solidFill>
+                  <a:srgbClr val="2C3E50"/>
+                </a:solidFill>
+                <a:latin typeface="Calibri"/>
+              </a:rPr>
+              <a:t>Future:</a:t>
+            </a:r>
+          </a:p>
+          <a:p>
+            <a:pPr algn="l" lvl="1"/>
+            <a:r>
+              <a:rPr sz="1000">
+                <a:latin typeface="Calibri"/>
+              </a:rPr>
+              <a:t>• Spark Structured Streaming (real-time)</a:t>
+            </a:r>
+          </a:p>
+          <a:p>
+            <a:pPr algn="l" lvl="1"/>
+            <a:r>
+              <a:rPr sz="1000">
+                <a:latin typeface="Calibri"/>
+              </a:rPr>
+              <a:t>• ML models: predict Decision Impact</a:t>
+            </a:r>
+          </a:p>
+          <a:p>
+            <a:pPr algn="l" lvl="1"/>
+            <a:r>
+              <a:rPr sz="1000">
+                <a:latin typeface="Calibri"/>
+              </a:rPr>
+              <a:t>• Automated threshold alerts</a:t>
+            </a:r>
+          </a:p>
+        </p:txBody>
+      </p:sp>
+      <p:pic>
+        <p:nvPicPr>
+          <p:cNvPr id="4" name="Picture 3" descr="03_quality_vs_impact_scatter.png"/>
+          <p:cNvPicPr>
+            <a:picLocks noChangeAspect="1"/>
+          </p:cNvPicPr>
+          <p:nvPr/>
+        </p:nvPicPr>
+        <p:blipFill>
+          <a:blip r:embed="rId2"/>
+          <a:stretch>
+            <a:fillRect/>
+          </a:stretch>
+        </p:blipFill>
+        <p:spPr>
+          <a:xfrm>
+            <a:off x="4663440" y="1280160"/>
+            <a:ext cx="4206240" cy="2560320"/>
+          </a:xfrm>
+          <a:prstGeom prst="rect">
+            <a:avLst/>
+          </a:prstGeom>
+        </p:spPr>
+      </p:pic>
+      <p:pic>
+        <p:nvPicPr>
+          <p:cNvPr id="5" name="Picture 4" descr="06_decision_type_pie.png"/>
+          <p:cNvPicPr>
+            <a:picLocks noChangeAspect="1"/>
+          </p:cNvPicPr>
+          <p:nvPr/>
+        </p:nvPicPr>
+        <p:blipFill>
+          <a:blip r:embed="rId3"/>
+          <a:stretch>
+            <a:fillRect/>
+          </a:stretch>
+        </p:blipFill>
+        <p:spPr>
+          <a:xfrm>
+            <a:off x="5120640" y="4023360"/>
+            <a:ext cx="3200400" cy="2560320"/>
+          </a:xfrm>
+          <a:prstGeom prst="rect">
+            <a:avLst/>
+          </a:prstGeom>
+        </p:spPr>
+      </p:pic>
     </p:spTree>
   </p:cSld>
   <p:clrMapOvr>
@@ -3762,61 +4170,145 @@
           <a:p>
             <a:pPr/>
             <a:r>
-              <a:rPr sz="1400"/>
+              <a:rPr sz="1600" b="1">
+                <a:solidFill>
+                  <a:srgbClr val="2C3E50"/>
+                </a:solidFill>
+                <a:latin typeface="Calibri"/>
+              </a:rPr>
               <a:t>Summary:</a:t>
             </a:r>
           </a:p>
           <a:p>
             <a:r>
-              <a:rPr sz="1400"/>
+              <a:rPr sz="800" b="0">
+                <a:latin typeface="Calibri"/>
+              </a:rPr>
               <a:t/>
             </a:r>
           </a:p>
           <a:p>
             <a:r>
-              <a:rPr sz="1400"/>
-              <a:t>Problem: Organizations fail to leverage data for high-quality decisions due to poor data quality, fragmented pipelines, and lack of actionable insights.</a:t>
-            </a:r>
-          </a:p>
-          <a:p>
-            <a:r>
-              <a:rPr sz="1400"/>
+              <a:rPr sz="1300" b="1">
+                <a:solidFill>
+                  <a:srgbClr val="C0392B"/>
+                </a:solidFill>
+                <a:latin typeface="Calibri"/>
+              </a:rPr>
+              <a:t>Problem:</a:t>
+            </a:r>
+          </a:p>
+          <a:p>
+            <a:r>
+              <a:rPr sz="1200" b="0">
+                <a:latin typeface="Calibri"/>
+              </a:rPr>
+              <a:t>Organizations fail to leverage data for high-quality decisions</a:t>
+            </a:r>
+          </a:p>
+          <a:p>
+            <a:r>
+              <a:rPr sz="1200" b="0">
+                <a:latin typeface="Calibri"/>
+              </a:rPr>
+              <a:t>due to poor data quality, fragmented pipelines, and lack of insights.</a:t>
+            </a:r>
+          </a:p>
+          <a:p>
+            <a:r>
+              <a:rPr sz="800" b="0">
+                <a:latin typeface="Calibri"/>
+              </a:rPr>
               <a:t/>
             </a:r>
           </a:p>
           <a:p>
             <a:r>
-              <a:rPr sz="1400"/>
-              <a:t>Solution: Built a complete big data pipeline using PySpark, GCP, and Streamlit that ingests 123,847 records, cleans and transforms the data, and delivers interactive dashboards with business insights.</a:t>
-            </a:r>
-          </a:p>
-          <a:p>
-            <a:r>
-              <a:rPr sz="1400"/>
+              <a:rPr sz="1300" b="1">
+                <a:solidFill>
+                  <a:srgbClr val="2980B9"/>
+                </a:solidFill>
+                <a:latin typeface="Calibri"/>
+              </a:rPr>
+              <a:t>Solution:</a:t>
+            </a:r>
+          </a:p>
+          <a:p>
+            <a:r>
+              <a:rPr sz="1200" b="0">
+                <a:latin typeface="Calibri"/>
+              </a:rPr>
+              <a:t>Complete big data pipeline: PySpark + GCP + Streamlit</a:t>
+            </a:r>
+          </a:p>
+          <a:p>
+            <a:r>
+              <a:rPr sz="1200" b="0">
+                <a:latin typeface="Calibri"/>
+              </a:rPr>
+              <a:t>123,847 records → Clean → Transform → Parquet → Dashboard</a:t>
+            </a:r>
+          </a:p>
+          <a:p>
+            <a:r>
+              <a:rPr sz="800" b="0">
+                <a:latin typeface="Calibri"/>
+              </a:rPr>
               <a:t/>
             </a:r>
           </a:p>
           <a:p>
             <a:r>
-              <a:rPr sz="1400"/>
-              <a:t>Outcome: Identified Data Quality (r=0.74) and Error Rate (r=-0.77) as the top drivers of decision effectiveness. Derived 5 actionable decisions projected to improve decision quality by 18–25%.</a:t>
-            </a:r>
-          </a:p>
-          <a:p>
-            <a:r>
-              <a:rPr sz="1400"/>
+              <a:rPr sz="1300" b="1">
+                <a:solidFill>
+                  <a:srgbClr val="27AE60"/>
+                </a:solidFill>
+                <a:latin typeface="Calibri"/>
+              </a:rPr>
+              <a:t>Outcome:</a:t>
+            </a:r>
+          </a:p>
+          <a:p>
+            <a:r>
+              <a:rPr sz="1200" b="0">
+                <a:latin typeface="Calibri"/>
+              </a:rPr>
+              <a:t>Data Quality (r=0.74) and Error Rate (r=–0.77) identified as top drivers.</a:t>
+            </a:r>
+          </a:p>
+          <a:p>
+            <a:r>
+              <a:rPr sz="1200" b="0">
+                <a:latin typeface="Calibri"/>
+              </a:rPr>
+              <a:t>5 actionable decisions projected to improve quality by 18–25%.</a:t>
+            </a:r>
+          </a:p>
+          <a:p>
+            <a:r>
+              <a:rPr sz="1000" b="0">
+                <a:latin typeface="Calibri"/>
+              </a:rPr>
               <a:t/>
             </a:r>
           </a:p>
           <a:p>
             <a:r>
-              <a:rPr sz="1400"/>
+              <a:rPr sz="1000" b="0">
+                <a:latin typeface="Calibri"/>
+              </a:rPr>
               <a:t/>
             </a:r>
           </a:p>
           <a:p>
-            <a:r>
-              <a:rPr sz="1400"/>
+            <a:pPr algn="ctr"/>
+            <a:r>
+              <a:rPr sz="2000" b="1">
+                <a:solidFill>
+                  <a:srgbClr val="2C3E50"/>
+                </a:solidFill>
+                <a:latin typeface="Calibri"/>
+              </a:rPr>
               <a:t>Thank You</a:t>
             </a:r>
           </a:p>

</xml_diff>